<commit_message>
Update virtual cybersecurity poster PPTX
Replace the digital poster (Diplomarbeit/doc/HTL-DA_Digitales_Poster_VirtuelleCybersecurity-TestumgebungMitIDS.pptx) with an updated PPTX file containing revisions to the content and layout for the virtual cybersecurity test environment with IDS.
</commit_message>
<xml_diff>
--- a/Diplomarbeit/doc/HTL-DA_Digitales_Poster_VirtuelleCybersecurity-TestumgebungMitIDS.pptx
+++ b/Diplomarbeit/doc/HTL-DA_Digitales_Poster_VirtuelleCybersecurity-TestumgebungMitIDS.pptx
@@ -226,7 +226,7 @@
           <a:p>
             <a:fld id="{47747906-58F8-41D5-91B4-3B180173CB0D}" type="datetimeFigureOut">
               <a:rPr lang="de-DE" smtClean="0"/>
-              <a:t>27.02.2026</a:t>
+              <a:t>06.03.2026</a:t>
             </a:fld>
             <a:endParaRPr lang="de-DE"/>
           </a:p>
@@ -403,7 +403,7 @@
           <a:p>
             <a:fld id="{B4145E3C-60A8-4CC3-BBE9-1D0B1ECC86AD}" type="datetimeFigureOut">
               <a:rPr lang="de-DE" smtClean="0"/>
-              <a:t>27.02.2026</a:t>
+              <a:t>06.03.2026</a:t>
             </a:fld>
             <a:endParaRPr lang="de-DE"/>
           </a:p>
@@ -2127,8 +2127,8 @@
         </p:nvSpPr>
         <p:spPr>
           <a:xfrm>
-            <a:off x="1371600" y="29290557"/>
-            <a:ext cx="13766006" cy="7945485"/>
+            <a:off x="935038" y="30663694"/>
+            <a:ext cx="14202568" cy="5201562"/>
           </a:xfrm>
         </p:spPr>
         <p:txBody>
@@ -2138,15 +2138,54 @@
             <a:pPr algn="l"/>
             <a:r>
               <a:rPr lang="de-DE" b="0" dirty="0"/>
-              <a:t>Im praktischen Teil wurde eine vollständige virtuelle Übungsumgebung aufgebaut und erfolgreich getestet. Typische Angriffsszenarien konnten realitätsnah simuliert werden, ohne produktive Systeme zu gefährden. Das eingesetzte Überwachungssystem erkannte verdächtige Aktivitäten und stellte sie zentral und verständlich dar. Dadurch konnte der Ablauf eines Angriffs Schritt für Schritt nachvollzogen werden. Insgesamt zeigt das Ergebnis, dass die Lösung für praxisnahen, fairen und modernen </a:t>
-            </a:r>
-            <a:r>
-              <a:rPr lang="de-DE" b="0" dirty="0" err="1"/>
+              <a:t>Im praktischen Teil wurden eine </a:t>
+            </a:r>
+            <a:r>
+              <a:rPr lang="de-DE" dirty="0"/>
+              <a:t>virtuelle Übungsumgebung</a:t>
+            </a:r>
+            <a:r>
+              <a:rPr lang="de-DE" b="0" dirty="0"/>
+              <a:t> aufgebaut und umfassend getestet. Typische </a:t>
+            </a:r>
+            <a:r>
+              <a:rPr lang="de-DE" dirty="0"/>
+              <a:t>Angriffsszenarien</a:t>
+            </a:r>
+            <a:r>
+              <a:rPr lang="de-DE" b="0" dirty="0"/>
+              <a:t> konnten realitätsnah simuliert werden, ohne echte Systeme zu gefährden. Das </a:t>
+            </a:r>
+            <a:r>
+              <a:rPr lang="de-DE" dirty="0"/>
+              <a:t>Überwachungssystem (IDS)</a:t>
+            </a:r>
+            <a:r>
+              <a:rPr lang="de-DE" b="0" dirty="0"/>
+              <a:t> erkannte verdächtige Aktivitäten und visualisierte diese zentral.</a:t>
+            </a:r>
+            <a:br>
+              <a:rPr lang="de-DE" dirty="0"/>
+            </a:br>
+            <a:r>
+              <a:rPr lang="de-DE" b="0" dirty="0"/>
+              <a:t>Ergebnis: </a:t>
+            </a:r>
+            <a:r>
+              <a:rPr lang="de-DE" dirty="0"/>
+              <a:t>nachvollziehbare Angriffsabläufe, geeignet für modernen </a:t>
+            </a:r>
+            <a:r>
+              <a:rPr lang="de-DE" dirty="0" err="1"/>
               <a:t>Cybersecurity</a:t>
             </a:r>
             <a:r>
+              <a:rPr lang="de-DE" dirty="0"/>
+              <a:t>-Unterricht</a:t>
+            </a:r>
+            <a:r>
               <a:rPr lang="de-DE" b="0" dirty="0"/>
-              <a:t>-Unterricht sehr gut geeignet ist.</a:t>
+              <a:t>.</a:t>
             </a:r>
             <a:endParaRPr lang="de-AT" dirty="0"/>
           </a:p>
@@ -2203,8 +2242,8 @@
         </p:nvSpPr>
         <p:spPr>
           <a:xfrm>
-            <a:off x="15971520" y="18521319"/>
-            <a:ext cx="13350240" cy="7945485"/>
+            <a:off x="15393826" y="19347331"/>
+            <a:ext cx="13946349" cy="6894228"/>
           </a:xfrm>
         </p:spPr>
         <p:txBody>
@@ -2214,7 +2253,109 @@
             <a:pPr algn="l"/>
             <a:r>
               <a:rPr lang="de-DE" b="0" dirty="0"/>
-              <a:t>Im theoretischen Teil wurde untersucht, wie Angriffe in Computernetzwerken entstehen und welche Schutzmaßnahmen besonders wirksam sind. Zusätzlich wurden verschiedene Lösungen zur Angriffserkennung verglichen. Zentrale Erkenntnis: Nicht einzelne Tools, sondern das Zusammenspiel aus klaren Sicherheitsregeln, starken Passwörtern, sinnvollen Berechtigungen und laufender Überwachung schützt ein Netzwerk nachhaltig. Dadurch können Sicherheitsvorfälle früh erkannt und begrenzt werden.</a:t>
+              <a:t>Im theoretischen Teil wurden </a:t>
+            </a:r>
+            <a:r>
+              <a:rPr lang="de-DE" dirty="0"/>
+              <a:t>Angriffsabläufe</a:t>
+            </a:r>
+            <a:r>
+              <a:rPr lang="de-DE" b="0" dirty="0"/>
+              <a:t>, </a:t>
+            </a:r>
+            <a:r>
+              <a:rPr lang="de-DE" dirty="0"/>
+              <a:t>Risiken</a:t>
+            </a:r>
+            <a:r>
+              <a:rPr lang="de-DE" b="0" dirty="0"/>
+              <a:t> und </a:t>
+            </a:r>
+            <a:r>
+              <a:rPr lang="de-DE" dirty="0"/>
+              <a:t>wirksame Schutzmaßnahmen</a:t>
+            </a:r>
+            <a:r>
+              <a:rPr lang="de-DE" b="0" dirty="0"/>
+              <a:t> untersucht. Außerdem erfolgte ein Vergleich von </a:t>
+            </a:r>
+            <a:r>
+              <a:rPr lang="de-DE" dirty="0"/>
+              <a:t>Angriffserkennungssystemen (IDS)</a:t>
+            </a:r>
+            <a:r>
+              <a:rPr lang="de-DE" b="0" dirty="0"/>
+              <a:t>.</a:t>
+            </a:r>
+            <a:br>
+              <a:rPr lang="de-DE" dirty="0"/>
+            </a:br>
+            <a:r>
+              <a:rPr lang="de-DE" b="0" dirty="0"/>
+              <a:t>Kernaussage: </a:t>
+            </a:r>
+            <a:r>
+              <a:rPr lang="de-DE" dirty="0"/>
+              <a:t>Sicherheitsregeln</a:t>
+            </a:r>
+            <a:r>
+              <a:rPr lang="de-DE" b="0" dirty="0"/>
+              <a:t>, </a:t>
+            </a:r>
+            <a:r>
+              <a:rPr lang="de-DE" dirty="0"/>
+              <a:t>starke Passwörter</a:t>
+            </a:r>
+            <a:r>
+              <a:rPr lang="de-DE" b="0" dirty="0"/>
+              <a:t>, </a:t>
+            </a:r>
+            <a:r>
+              <a:rPr lang="de-DE" dirty="0"/>
+              <a:t>klare Berechtigungen</a:t>
+            </a:r>
+            <a:r>
+              <a:rPr lang="de-DE" b="0" dirty="0"/>
+              <a:t> und </a:t>
+            </a:r>
+            <a:r>
+              <a:rPr lang="de-DE" dirty="0"/>
+              <a:t>kontinuierliches Monitoring</a:t>
+            </a:r>
+            <a:r>
+              <a:rPr lang="de-DE" b="0" dirty="0"/>
+              <a:t> sind entscheidend</a:t>
+            </a:r>
+            <a:br>
+              <a:rPr lang="de-DE" dirty="0"/>
+            </a:br>
+            <a:r>
+              <a:rPr lang="de-DE" b="0" dirty="0"/>
+              <a:t>Ergebnis: </a:t>
+            </a:r>
+            <a:r>
+              <a:rPr lang="de-DE" dirty="0"/>
+              <a:t>frühe Erkennung</a:t>
+            </a:r>
+            <a:r>
+              <a:rPr lang="de-DE" b="0" dirty="0"/>
+              <a:t>, </a:t>
+            </a:r>
+            <a:r>
+              <a:rPr lang="de-DE" dirty="0"/>
+              <a:t>schnelle Reaktion</a:t>
+            </a:r>
+            <a:r>
+              <a:rPr lang="de-DE" b="0" dirty="0"/>
+              <a:t>, </a:t>
+            </a:r>
+            <a:r>
+              <a:rPr lang="de-DE" dirty="0"/>
+              <a:t>geringere Schäden</a:t>
+            </a:r>
+            <a:r>
+              <a:rPr lang="de-DE" b="0" dirty="0"/>
+              <a:t>.</a:t>
             </a:r>
             <a:endParaRPr lang="de-AT" dirty="0"/>
           </a:p>
@@ -2339,10 +2480,10 @@
       </p:pic>
       <p:pic>
         <p:nvPicPr>
-          <p:cNvPr id="18" name="Bildplatzhalter 17" descr="Ein Bild, das Text, Screenshot, Schrift, Logo enthält.&#10;&#10;KI-generierte Inhalte können fehlerhaft sein.">
+          <p:cNvPr id="16" name="Bildplatzhalter 15">
             <a:extLst>
               <a:ext uri="{FF2B5EF4-FFF2-40B4-BE49-F238E27FC236}">
-                <a16:creationId xmlns:a16="http://schemas.microsoft.com/office/drawing/2014/main" id="{11A5B3F9-B663-6A40-BF45-988125B3E73D}"/>
+                <a16:creationId xmlns:a16="http://schemas.microsoft.com/office/drawing/2014/main" id="{1F46CF9D-2B87-954B-502A-49F82358FDF8}"/>
               </a:ext>
             </a:extLst>
           </p:cNvPr>
@@ -2354,16 +2495,22 @@
           </p:nvPr>
         </p:nvPicPr>
         <p:blipFill>
-          <a:blip r:embed="rId3"/>
-          <a:srcRect l="12239" t="17815" r="13581" b="1716"/>
+          <a:blip r:embed="rId3">
+            <a:extLst>
+              <a:ext uri="{28A0092B-C50C-407E-A947-70E740481C1C}">
+                <a14:useLocalDpi xmlns:a14="http://schemas.microsoft.com/office/drawing/2010/main" val="0"/>
+              </a:ext>
+            </a:extLst>
+          </a:blip>
+          <a:srcRect l="8566" t="3074" r="2168" b="-3074"/>
           <a:stretch>
             <a:fillRect/>
           </a:stretch>
         </p:blipFill>
         <p:spPr>
           <a:xfrm>
-            <a:off x="3246120" y="17245116"/>
-            <a:ext cx="9728200" cy="10552904"/>
+            <a:off x="593362" y="18201675"/>
+            <a:ext cx="14049898" cy="9772510"/>
           </a:xfrm>
           <a:prstGeom prst="rect">
             <a:avLst/>
@@ -3309,21 +3456,6 @@
 </file>
 
 <file path=customXml/item1.xml><?xml version="1.0" encoding="utf-8"?>
-<?mso-contentType ?>
-<FormTemplates xmlns="http://schemas.microsoft.com/sharepoint/v3/contenttype/forms">
-  <Display>DocumentLibraryForm</Display>
-  <Edit>DocumentLibraryForm</Edit>
-  <New>DocumentLibraryForm</New>
-</FormTemplates>
-</file>
-
-<file path=customXml/item2.xml><?xml version="1.0" encoding="utf-8"?>
-<p:properties xmlns:p="http://schemas.microsoft.com/office/2006/metadata/properties" xmlns:xsi="http://www.w3.org/2001/XMLSchema-instance" xmlns:pc="http://schemas.microsoft.com/office/infopath/2007/PartnerControls">
-  <documentManagement/>
-</p:properties>
-</file>
-
-<file path=customXml/item3.xml><?xml version="1.0" encoding="utf-8"?>
 <ct:contentTypeSchema xmlns:ct="http://schemas.microsoft.com/office/2006/metadata/contentType" xmlns:ma="http://schemas.microsoft.com/office/2006/metadata/properties/metaAttributes" ct:_="" ma:_="" ma:contentTypeName="Document" ma:contentTypeID="0x01010034CB4D94694C6C4497074175C0CB9EC7" ma:contentTypeVersion="9" ma:contentTypeDescription="Create a new document." ma:contentTypeScope="" ma:versionID="978871d5ecab1c5bc96bae753ca5201c">
   <xsd:schema xmlns:xsd="http://www.w3.org/2001/XMLSchema" xmlns:xs="http://www.w3.org/2001/XMLSchema" xmlns:p="http://schemas.microsoft.com/office/2006/metadata/properties" xmlns:ns2="95073dbd-529e-4168-8b89-5095f680e838" targetNamespace="http://schemas.microsoft.com/office/2006/metadata/properties" ma:root="true" ma:fieldsID="683fdc4ed8203e5744d34fe0db2929ab" ns2:_="">
     <xsd:import namespace="95073dbd-529e-4168-8b89-5095f680e838"/>
@@ -3497,24 +3629,22 @@
 </ct:contentTypeSchema>
 </file>
 
-<file path=customXml/itemProps1.xml><?xml version="1.0" encoding="utf-8"?>
-<ds:datastoreItem xmlns:ds="http://schemas.openxmlformats.org/officeDocument/2006/customXml" ds:itemID="{33CC1DD1-960A-4156-AAD2-FBE002C9E09E}">
-  <ds:schemaRefs>
-    <ds:schemaRef ds:uri="http://schemas.microsoft.com/sharepoint/v3/contenttype/forms"/>
-  </ds:schemaRefs>
-</ds:datastoreItem>
+<file path=customXml/item2.xml><?xml version="1.0" encoding="utf-8"?>
+<p:properties xmlns:p="http://schemas.microsoft.com/office/2006/metadata/properties" xmlns:xsi="http://www.w3.org/2001/XMLSchema-instance" xmlns:pc="http://schemas.microsoft.com/office/infopath/2007/PartnerControls">
+  <documentManagement/>
+</p:properties>
 </file>
 
-<file path=customXml/itemProps2.xml><?xml version="1.0" encoding="utf-8"?>
-<ds:datastoreItem xmlns:ds="http://schemas.openxmlformats.org/officeDocument/2006/customXml" ds:itemID="{3B2E5DC6-0500-44EE-AED5-81508B4384EA}">
-  <ds:schemaRefs>
-    <ds:schemaRef ds:uri="http://schemas.microsoft.com/office/2006/metadata/properties"/>
-    <ds:schemaRef ds:uri="http://schemas.microsoft.com/office/infopath/2007/PartnerControls"/>
-  </ds:schemaRefs>
-</ds:datastoreItem>
+<file path=customXml/item3.xml><?xml version="1.0" encoding="utf-8"?>
+<?mso-contentType ?>
+<FormTemplates xmlns="http://schemas.microsoft.com/sharepoint/v3/contenttype/forms">
+  <Display>DocumentLibraryForm</Display>
+  <Edit>DocumentLibraryForm</Edit>
+  <New>DocumentLibraryForm</New>
+</FormTemplates>
 </file>
 
-<file path=customXml/itemProps3.xml><?xml version="1.0" encoding="utf-8"?>
+<file path=customXml/itemProps1.xml><?xml version="1.0" encoding="utf-8"?>
 <ds:datastoreItem xmlns:ds="http://schemas.openxmlformats.org/officeDocument/2006/customXml" ds:itemID="{6B8603C9-7727-411E-BD6C-694A8ED01DE9}">
   <ds:schemaRefs>
     <ds:schemaRef ds:uri="http://schemas.microsoft.com/office/2006/metadata/contentType"/>
@@ -3530,4 +3660,21 @@
     <ds:schemaRef ds:uri="http://schemas.microsoft.com/internal/obd"/>
   </ds:schemaRefs>
 </ds:datastoreItem>
+</file>
+
+<file path=customXml/itemProps2.xml><?xml version="1.0" encoding="utf-8"?>
+<ds:datastoreItem xmlns:ds="http://schemas.openxmlformats.org/officeDocument/2006/customXml" ds:itemID="{3B2E5DC6-0500-44EE-AED5-81508B4384EA}">
+  <ds:schemaRefs>
+    <ds:schemaRef ds:uri="http://schemas.microsoft.com/office/2006/metadata/properties"/>
+    <ds:schemaRef ds:uri="http://schemas.microsoft.com/office/infopath/2007/PartnerControls"/>
+  </ds:schemaRefs>
+</ds:datastoreItem>
+</file>
+
+<file path=customXml/itemProps3.xml><?xml version="1.0" encoding="utf-8"?>
+<ds:datastoreItem xmlns:ds="http://schemas.openxmlformats.org/officeDocument/2006/customXml" ds:itemID="{33CC1DD1-960A-4156-AAD2-FBE002C9E09E}">
+  <ds:schemaRefs>
+    <ds:schemaRef ds:uri="http://schemas.microsoft.com/sharepoint/v3/contenttype/forms"/>
+  </ds:schemaRefs>
+</ds:datastoreItem>
 </file>
</xml_diff>